<commit_message>
docs: drop cover-slide tagline from the locked branding spec
The tagline line ('A virtual fitting room with size recommendations and
tailored advice') is removed from the technical deck's title slide (a
manual edit, now committed) and CLAUDE.md's branding spec is updated to
match: the title slide now ends at 'Debie Galleros · July 2026' followed
by each deck's existing presentation-type + links line, with no separate
tagline. Keeps Phase 6's deck regeneration from silently re-adding it.
The business deck still carries the old tagline + title — picked up
when Phase 6 regenerates both decks together.

Co-Authored-By: Claude Fable 5 <noreply@anthropic.com>
</commit_message>
<xml_diff>
--- a/submission/Debie_Galleros_Pillar5_CapstoneProject_TechnicalDeck.pptx
+++ b/submission/Debie_Galleros_Pillar5_CapstoneProject_TechnicalDeck.pptx
@@ -312,7 +312,7 @@
           <a:p>
             <a:fld id="{5BCAD085-E8A6-8845-BD4E-CB4CCA059FC4}" type="datetimeFigureOut">
               <a:rPr lang="en-US" smtClean="0"/>
-              <a:t>7/12/26</a:t>
+              <a:t>7/13/26</a:t>
             </a:fld>
             <a:endParaRPr lang="en-US"/>
           </a:p>
@@ -480,7 +480,7 @@
           <a:p>
             <a:fld id="{5BCAD085-E8A6-8845-BD4E-CB4CCA059FC4}" type="datetimeFigureOut">
               <a:rPr lang="en-US" smtClean="0"/>
-              <a:t>7/12/26</a:t>
+              <a:t>7/13/26</a:t>
             </a:fld>
             <a:endParaRPr lang="en-US"/>
           </a:p>
@@ -658,7 +658,7 @@
           <a:p>
             <a:fld id="{5BCAD085-E8A6-8845-BD4E-CB4CCA059FC4}" type="datetimeFigureOut">
               <a:rPr lang="en-US" smtClean="0"/>
-              <a:t>7/12/26</a:t>
+              <a:t>7/13/26</a:t>
             </a:fld>
             <a:endParaRPr lang="en-US"/>
           </a:p>
@@ -826,7 +826,7 @@
           <a:p>
             <a:fld id="{5BCAD085-E8A6-8845-BD4E-CB4CCA059FC4}" type="datetimeFigureOut">
               <a:rPr lang="en-US" smtClean="0"/>
-              <a:t>7/12/26</a:t>
+              <a:t>7/13/26</a:t>
             </a:fld>
             <a:endParaRPr lang="en-US"/>
           </a:p>
@@ -1071,7 +1071,7 @@
           <a:p>
             <a:fld id="{5BCAD085-E8A6-8845-BD4E-CB4CCA059FC4}" type="datetimeFigureOut">
               <a:rPr lang="en-US" smtClean="0"/>
-              <a:t>7/12/26</a:t>
+              <a:t>7/13/26</a:t>
             </a:fld>
             <a:endParaRPr lang="en-US"/>
           </a:p>
@@ -1356,7 +1356,7 @@
           <a:p>
             <a:fld id="{5BCAD085-E8A6-8845-BD4E-CB4CCA059FC4}" type="datetimeFigureOut">
               <a:rPr lang="en-US" smtClean="0"/>
-              <a:t>7/12/26</a:t>
+              <a:t>7/13/26</a:t>
             </a:fld>
             <a:endParaRPr lang="en-US"/>
           </a:p>
@@ -1775,7 +1775,7 @@
           <a:p>
             <a:fld id="{5BCAD085-E8A6-8845-BD4E-CB4CCA059FC4}" type="datetimeFigureOut">
               <a:rPr lang="en-US" smtClean="0"/>
-              <a:t>7/12/26</a:t>
+              <a:t>7/13/26</a:t>
             </a:fld>
             <a:endParaRPr lang="en-US"/>
           </a:p>
@@ -1892,7 +1892,7 @@
           <a:p>
             <a:fld id="{5BCAD085-E8A6-8845-BD4E-CB4CCA059FC4}" type="datetimeFigureOut">
               <a:rPr lang="en-US" smtClean="0"/>
-              <a:t>7/12/26</a:t>
+              <a:t>7/13/26</a:t>
             </a:fld>
             <a:endParaRPr lang="en-US"/>
           </a:p>
@@ -1987,7 +1987,7 @@
           <a:p>
             <a:fld id="{5BCAD085-E8A6-8845-BD4E-CB4CCA059FC4}" type="datetimeFigureOut">
               <a:rPr lang="en-US" smtClean="0"/>
-              <a:t>7/12/26</a:t>
+              <a:t>7/13/26</a:t>
             </a:fld>
             <a:endParaRPr lang="en-US"/>
           </a:p>
@@ -2262,7 +2262,7 @@
           <a:p>
             <a:fld id="{5BCAD085-E8A6-8845-BD4E-CB4CCA059FC4}" type="datetimeFigureOut">
               <a:rPr lang="en-US" smtClean="0"/>
-              <a:t>7/12/26</a:t>
+              <a:t>7/13/26</a:t>
             </a:fld>
             <a:endParaRPr lang="en-US"/>
           </a:p>
@@ -2514,7 +2514,7 @@
           <a:p>
             <a:fld id="{5BCAD085-E8A6-8845-BD4E-CB4CCA059FC4}" type="datetimeFigureOut">
               <a:rPr lang="en-US" smtClean="0"/>
-              <a:t>7/12/26</a:t>
+              <a:t>7/13/26</a:t>
             </a:fld>
             <a:endParaRPr lang="en-US"/>
           </a:p>
@@ -2725,7 +2725,7 @@
           <a:p>
             <a:fld id="{5BCAD085-E8A6-8845-BD4E-CB4CCA059FC4}" type="datetimeFigureOut">
               <a:rPr lang="en-US" smtClean="0"/>
-              <a:t>7/12/26</a:t>
+              <a:t>7/13/26</a:t>
             </a:fld>
             <a:endParaRPr lang="en-US"/>
           </a:p>
@@ -3303,48 +3303,6 @@
       </p:sp>
       <p:sp>
         <p:nvSpPr>
-          <p:cNvPr id="7" name="TextBox 6"/>
-          <p:cNvSpPr txBox="1"/>
-          <p:nvPr/>
-        </p:nvSpPr>
-        <p:spPr>
-          <a:xfrm>
-            <a:off x="1097280" y="5047488"/>
-            <a:ext cx="9994392" cy="189411"/>
-          </a:xfrm>
-          <a:prstGeom prst="rect">
-            <a:avLst/>
-          </a:prstGeom>
-          <a:noFill/>
-        </p:spPr>
-        <p:txBody>
-          <a:bodyPr wrap="square" lIns="0" tIns="0" rIns="0" bIns="0">
-            <a:spAutoFit/>
-          </a:bodyPr>
-          <a:lstStyle/>
-          <a:p>
-            <a:pPr algn="ctr">
-              <a:lnSpc>
-                <a:spcPct val="106000"/>
-              </a:lnSpc>
-              <a:spcAft>
-                <a:spcPts val="600"/>
-              </a:spcAft>
-            </a:pPr>
-            <a:r>
-              <a:rPr sz="1250" b="0" i="1" dirty="0">
-                <a:solidFill>
-                  <a:srgbClr val="595959"/>
-                </a:solidFill>
-                <a:latin typeface="Arial"/>
-              </a:rPr>
-              <a:t>A virtual fitting room with size recommendations and tailored advice</a:t>
-            </a:r>
-          </a:p>
-        </p:txBody>
-      </p:sp>
-      <p:sp>
-        <p:nvSpPr>
           <p:cNvPr id="8" name="TextBox 7"/>
           <p:cNvSpPr txBox="1"/>
           <p:nvPr/>
@@ -3390,6 +3348,14 @@
   <p:clrMapOvr>
     <a:masterClrMapping/>
   </p:clrMapOvr>
+  <mc:AlternateContent xmlns:mc="http://schemas.openxmlformats.org/markup-compatibility/2006">
+    <mc:Choice xmlns:p14="http://schemas.microsoft.com/office/powerpoint/2010/main" Requires="p14">
+      <p:transition spd="slow" p14:dur="2000" advTm="1733"/>
+    </mc:Choice>
+    <mc:Fallback>
+      <p:transition spd="slow" advTm="1733"/>
+    </mc:Fallback>
+  </mc:AlternateContent>
 </p:sld>
 </file>
 

</xml_diff>